<commit_message>
Change batch files into gitsuite.bat and modify project structure.
</commit_message>
<xml_diff>
--- a/document/v0.3_structure.pptx
+++ b/document/v0.3_structure.pptx
@@ -107,6 +107,11 @@
       </a:defRPr>
     </a:lvl9pPr>
   </p:defaultTextStyle>
+  <p:extLst>
+    <p:ext uri="{EFAFB233-063F-42B5-8137-9DF3F51BA10A}">
+      <p15:sldGuideLst xmlns:p15="http://schemas.microsoft.com/office/powerpoint/2012/main"/>
+    </p:ext>
+  </p:extLst>
 </p:presentation>
 </file>
 
@@ -192,7 +197,7 @@
           <a:p>
             <a:fld id="{F3C5B3B9-55AC-486A-BF33-48ED71FA835A}" type="datetimeFigureOut">
               <a:rPr lang="ko-KR" altLang="en-US" smtClean="0"/>
-              <a:t>2026-02-23</a:t>
+              <a:t>2026-03-19</a:t>
             </a:fld>
             <a:endParaRPr lang="ko-KR" altLang="en-US"/>
           </a:p>
@@ -690,7 +695,7 @@
           <a:p>
             <a:fld id="{CAF99402-F974-4970-8BDD-D701CA5AE6A6}" type="datetimeFigureOut">
               <a:rPr lang="ko-KR" altLang="en-US" smtClean="0"/>
-              <a:t>2026-02-23</a:t>
+              <a:t>2026-03-19</a:t>
             </a:fld>
             <a:endParaRPr lang="ko-KR" altLang="en-US"/>
           </a:p>
@@ -888,7 +893,7 @@
           <a:p>
             <a:fld id="{CAF99402-F974-4970-8BDD-D701CA5AE6A6}" type="datetimeFigureOut">
               <a:rPr lang="ko-KR" altLang="en-US" smtClean="0"/>
-              <a:t>2026-02-23</a:t>
+              <a:t>2026-03-19</a:t>
             </a:fld>
             <a:endParaRPr lang="ko-KR" altLang="en-US"/>
           </a:p>
@@ -1096,7 +1101,7 @@
           <a:p>
             <a:fld id="{CAF99402-F974-4970-8BDD-D701CA5AE6A6}" type="datetimeFigureOut">
               <a:rPr lang="ko-KR" altLang="en-US" smtClean="0"/>
-              <a:t>2026-02-23</a:t>
+              <a:t>2026-03-19</a:t>
             </a:fld>
             <a:endParaRPr lang="ko-KR" altLang="en-US"/>
           </a:p>
@@ -1294,7 +1299,7 @@
           <a:p>
             <a:fld id="{CAF99402-F974-4970-8BDD-D701CA5AE6A6}" type="datetimeFigureOut">
               <a:rPr lang="ko-KR" altLang="en-US" smtClean="0"/>
-              <a:t>2026-02-23</a:t>
+              <a:t>2026-03-19</a:t>
             </a:fld>
             <a:endParaRPr lang="ko-KR" altLang="en-US"/>
           </a:p>
@@ -1569,7 +1574,7 @@
           <a:p>
             <a:fld id="{CAF99402-F974-4970-8BDD-D701CA5AE6A6}" type="datetimeFigureOut">
               <a:rPr lang="ko-KR" altLang="en-US" smtClean="0"/>
-              <a:t>2026-02-23</a:t>
+              <a:t>2026-03-19</a:t>
             </a:fld>
             <a:endParaRPr lang="ko-KR" altLang="en-US"/>
           </a:p>
@@ -1834,7 +1839,7 @@
           <a:p>
             <a:fld id="{CAF99402-F974-4970-8BDD-D701CA5AE6A6}" type="datetimeFigureOut">
               <a:rPr lang="ko-KR" altLang="en-US" smtClean="0"/>
-              <a:t>2026-02-23</a:t>
+              <a:t>2026-03-19</a:t>
             </a:fld>
             <a:endParaRPr lang="ko-KR" altLang="en-US"/>
           </a:p>
@@ -2246,7 +2251,7 @@
           <a:p>
             <a:fld id="{CAF99402-F974-4970-8BDD-D701CA5AE6A6}" type="datetimeFigureOut">
               <a:rPr lang="ko-KR" altLang="en-US" smtClean="0"/>
-              <a:t>2026-02-23</a:t>
+              <a:t>2026-03-19</a:t>
             </a:fld>
             <a:endParaRPr lang="ko-KR" altLang="en-US"/>
           </a:p>
@@ -2387,7 +2392,7 @@
           <a:p>
             <a:fld id="{CAF99402-F974-4970-8BDD-D701CA5AE6A6}" type="datetimeFigureOut">
               <a:rPr lang="ko-KR" altLang="en-US" smtClean="0"/>
-              <a:t>2026-02-23</a:t>
+              <a:t>2026-03-19</a:t>
             </a:fld>
             <a:endParaRPr lang="ko-KR" altLang="en-US"/>
           </a:p>
@@ -2500,7 +2505,7 @@
           <a:p>
             <a:fld id="{CAF99402-F974-4970-8BDD-D701CA5AE6A6}" type="datetimeFigureOut">
               <a:rPr lang="ko-KR" altLang="en-US" smtClean="0"/>
-              <a:t>2026-02-23</a:t>
+              <a:t>2026-03-19</a:t>
             </a:fld>
             <a:endParaRPr lang="ko-KR" altLang="en-US"/>
           </a:p>
@@ -2811,7 +2816,7 @@
           <a:p>
             <a:fld id="{CAF99402-F974-4970-8BDD-D701CA5AE6A6}" type="datetimeFigureOut">
               <a:rPr lang="ko-KR" altLang="en-US" smtClean="0"/>
-              <a:t>2026-02-23</a:t>
+              <a:t>2026-03-19</a:t>
             </a:fld>
             <a:endParaRPr lang="ko-KR" altLang="en-US"/>
           </a:p>
@@ -3099,7 +3104,7 @@
           <a:p>
             <a:fld id="{CAF99402-F974-4970-8BDD-D701CA5AE6A6}" type="datetimeFigureOut">
               <a:rPr lang="ko-KR" altLang="en-US" smtClean="0"/>
-              <a:t>2026-02-23</a:t>
+              <a:t>2026-03-19</a:t>
             </a:fld>
             <a:endParaRPr lang="ko-KR" altLang="en-US"/>
           </a:p>
@@ -3340,7 +3345,7 @@
           <a:p>
             <a:fld id="{CAF99402-F974-4970-8BDD-D701CA5AE6A6}" type="datetimeFigureOut">
               <a:rPr lang="ko-KR" altLang="en-US" smtClean="0"/>
-              <a:t>2026-02-23</a:t>
+              <a:t>2026-03-19</a:t>
             </a:fld>
             <a:endParaRPr lang="ko-KR" altLang="en-US"/>
           </a:p>
@@ -3918,15 +3923,15 @@
           </p:cNvPr>
           <p:cNvCxnSpPr>
             <a:cxnSpLocks/>
-            <a:stCxn id="45" idx="0"/>
+            <a:stCxn id="4" idx="0"/>
             <a:endCxn id="30" idx="0"/>
           </p:cNvCxnSpPr>
           <p:nvPr/>
         </p:nvCxnSpPr>
         <p:spPr>
-          <a:xfrm flipH="1" flipV="1">
-            <a:off x="6095999" y="2928728"/>
-            <a:ext cx="2520001" cy="2520000"/>
+          <a:xfrm flipV="1">
+            <a:off x="6095997" y="2928728"/>
+            <a:ext cx="2" cy="2310000"/>
           </a:xfrm>
           <a:prstGeom prst="line">
             <a:avLst/>
@@ -4308,51 +4313,6 @@
           </a:fontRef>
         </p:style>
       </p:cxnSp>
-      <p:cxnSp>
-        <p:nvCxnSpPr>
-          <p:cNvPr id="10" name="직선 연결선 9">
-            <a:extLst>
-              <a:ext uri="{FF2B5EF4-FFF2-40B4-BE49-F238E27FC236}">
-                <a16:creationId xmlns:a16="http://schemas.microsoft.com/office/drawing/2014/main" id="{BF097EDD-CC6E-B27F-E1EB-868B9B4DEDB7}"/>
-              </a:ext>
-            </a:extLst>
-          </p:cNvPr>
-          <p:cNvCxnSpPr>
-            <a:cxnSpLocks/>
-            <a:stCxn id="45" idx="0"/>
-            <a:endCxn id="2" idx="2"/>
-          </p:cNvCxnSpPr>
-          <p:nvPr/>
-        </p:nvCxnSpPr>
-        <p:spPr>
-          <a:xfrm flipV="1">
-            <a:off x="8616000" y="3558729"/>
-            <a:ext cx="0" cy="1889999"/>
-          </a:xfrm>
-          <a:prstGeom prst="line">
-            <a:avLst/>
-          </a:prstGeom>
-          <a:ln w="19050">
-            <a:solidFill>
-              <a:schemeClr val="tx1"/>
-            </a:solidFill>
-          </a:ln>
-        </p:spPr>
-        <p:style>
-          <a:lnRef idx="1">
-            <a:schemeClr val="accent1"/>
-          </a:lnRef>
-          <a:fillRef idx="0">
-            <a:schemeClr val="accent1"/>
-          </a:fillRef>
-          <a:effectRef idx="0">
-            <a:schemeClr val="accent1"/>
-          </a:effectRef>
-          <a:fontRef idx="minor">
-            <a:schemeClr val="tx1"/>
-          </a:fontRef>
-        </p:style>
-      </p:cxnSp>
       <p:sp>
         <p:nvSpPr>
           <p:cNvPr id="4" name="순서도: 자기 디스크 3">
@@ -4367,7 +4327,7 @@
         </p:nvSpPr>
         <p:spPr>
           <a:xfrm>
-            <a:off x="7986000" y="4818728"/>
+            <a:off x="5465997" y="4818728"/>
             <a:ext cx="1260000" cy="1260000"/>
           </a:xfrm>
           <a:prstGeom prst="flowChartMagneticDisk">

</xml_diff>